<commit_message>
Slides: badged PPTX of sd-08-008
</commit_message>
<xml_diff>
--- a/system-design-101/vi/lessons/sd-08-008/slides/sd-08-008.pptx
+++ b/system-design-101/vi/lessons/sd-08-008/slides/sd-08-008.pptx
@@ -12333,7 +12333,7 @@
               <a:t>Một</a:t>
             </a:r>
             <a:r>
-              <a:rPr lang="en-US" sz="6900" dirty="0" spc="-1" kern="0">
+              <a:rPr lang="en-US" sz="6900" dirty="0" spc="30" kern="0">
                 <a:solidFill>
                   <a:srgbClr val="F3EEE3"/>
                 </a:solidFill>
@@ -12341,10 +12341,10 @@
                 <a:ea typeface="Bricolage Grotesque ExtraBold" pitchFamily="34" charset="-122"/>
                 <a:cs typeface="Bricolage Grotesque ExtraBold" pitchFamily="34" charset="-120"/>
               </a:rPr>
-              <a:t> từ</a:t>
-            </a:r>
-            <a:r>
-              <a:rPr lang="en-US" sz="6900" dirty="0" spc="-2" kern="0">
+              <a:t> mô-đun</a:t>
+            </a:r>
+            <a:r>
+              <a:rPr lang="en-US" sz="6900" dirty="0" spc="-1" kern="0">
                 <a:solidFill>
                   <a:srgbClr val="F3EEE3"/>
                 </a:solidFill>
@@ -12355,7 +12355,7 @@
               <a:t> cần</a:t>
             </a:r>
             <a:r>
-              <a:rPr lang="en-US" sz="6900" dirty="0" spc="2" kern="0">
+              <a:rPr lang="en-US" sz="6900" dirty="0" spc="1" kern="0">
                 <a:solidFill>
                   <a:srgbClr val="F3EEE3"/>
                 </a:solidFill>
@@ -12420,7 +12420,7 @@
               <a:buNone/>
             </a:pPr>
             <a:r>
-              <a:rPr lang="en-US" sz="2250" dirty="0" spc="2" kern="0">
+              <a:rPr lang="en-US" sz="1800" dirty="0" spc="-18" kern="0">
                 <a:solidFill>
                   <a:srgbClr val="14161C"/>
                 </a:solidFill>
@@ -12428,9 +12428,9 @@
                 <a:ea typeface="Be Vietnam Pro ExtraBold" pitchFamily="34" charset="-122"/>
                 <a:cs typeface="Be Vietnam Pro ExtraBold" pitchFamily="34" charset="-120"/>
               </a:rPr>
-              <a:t>XML</a:t>
-            </a:r>
-            <a:endParaRPr lang="en-US" sz="2250" dirty="0"/>
+              <a:t>ElementTree</a:t>
+            </a:r>
+            <a:endParaRPr lang="en-US" sz="1800" dirty="0"/>
           </a:p>
         </p:txBody>
       </p:sp>
@@ -12459,7 +12459,7 @@
               <a:buNone/>
             </a:pPr>
             <a:r>
-              <a:rPr lang="en-US" sz="1650" dirty="0" spc="-4" kern="0">
+              <a:rPr lang="en-US" sz="1650" dirty="0" spc="-16" kern="0">
                 <a:solidFill>
                   <a:srgbClr val="9AA0B5"/>
                 </a:solidFill>
@@ -12467,73 +12467,7 @@
                 <a:ea typeface="Be Vietnam Pro" pitchFamily="34" charset="-122"/>
                 <a:cs typeface="Be Vietnam Pro" pitchFamily="34" charset="-120"/>
               </a:rPr>
-              <a:t>Xtensible</a:t>
-            </a:r>
-            <a:r>
-              <a:rPr lang="en-US" sz="1650" dirty="0" spc="-1" kern="0">
-                <a:solidFill>
-                  <a:srgbClr val="9AA0B5"/>
-                </a:solidFill>
-                <a:latin typeface="Be Vietnam Pro" pitchFamily="34" charset="0"/>
-                <a:ea typeface="Be Vietnam Pro" pitchFamily="34" charset="-122"/>
-                <a:cs typeface="Be Vietnam Pro" pitchFamily="34" charset="-120"/>
-              </a:rPr>
-              <a:t> Markup</a:t>
-            </a:r>
-            <a:r>
-              <a:rPr lang="en-US" sz="1650" dirty="0" spc="-12" kern="0">
-                <a:solidFill>
-                  <a:srgbClr val="9AA0B5"/>
-                </a:solidFill>
-                <a:latin typeface="Be Vietnam Pro" pitchFamily="34" charset="0"/>
-                <a:ea typeface="Be Vietnam Pro" pitchFamily="34" charset="-122"/>
-                <a:cs typeface="Be Vietnam Pro" pitchFamily="34" charset="-120"/>
-              </a:rPr>
-              <a:t> Language</a:t>
-            </a:r>
-            <a:r>
-              <a:rPr lang="en-US" sz="1650" dirty="0" spc="3" kern="0">
-                <a:solidFill>
-                  <a:srgbClr val="9AA0B5"/>
-                </a:solidFill>
-                <a:latin typeface="Be Vietnam Pro" pitchFamily="34" charset="0"/>
-                <a:ea typeface="Be Vietnam Pro" pitchFamily="34" charset="-122"/>
-                <a:cs typeface="Be Vietnam Pro" pitchFamily="34" charset="-120"/>
-              </a:rPr>
-              <a:t> (X</a:t>
-            </a:r>
-            <a:r>
-              <a:rPr lang="en-US" sz="1650" dirty="0" spc="-6" kern="0">
-                <a:solidFill>
-                  <a:srgbClr val="9AA0B5"/>
-                </a:solidFill>
-                <a:latin typeface="Be Vietnam Pro" pitchFamily="34" charset="0"/>
-                <a:ea typeface="Be Vietnam Pro" pitchFamily="34" charset="-122"/>
-                <a:cs typeface="Be Vietnam Pro" pitchFamily="34" charset="-120"/>
-              </a:rPr>
-              <a:t> lấy</a:t>
-            </a:r>
-            <a:r>
-              <a:rPr lang="en-US" sz="1650" dirty="0" spc="4" kern="0">
-                <a:solidFill>
-                  <a:srgbClr val="9AA0B5"/>
-                </a:solidFill>
-                <a:latin typeface="Be Vietnam Pro" pitchFamily="34" charset="0"/>
-                <a:ea typeface="Be Vietnam Pro" pitchFamily="34" charset="-122"/>
-                <a:cs typeface="Be Vietnam Pro" pitchFamily="34" charset="-120"/>
-              </a:rPr>
-              <a:t> từ</a:t>
-            </a:r>
-            <a:r>
-              <a:rPr lang="en-US" sz="1650" dirty="0" spc="-8" kern="0">
-                <a:solidFill>
-                  <a:srgbClr val="9AA0B5"/>
-                </a:solidFill>
-                <a:latin typeface="Be Vietnam Pro" pitchFamily="34" charset="0"/>
-                <a:ea typeface="Be Vietnam Pro" pitchFamily="34" charset="-122"/>
-                <a:cs typeface="Be Vietnam Pro" pitchFamily="34" charset="-120"/>
-              </a:rPr>
-              <a:t> eXtensible)</a:t>
+              <a:t>xml.etree.ElementTree</a:t>
             </a:r>
             <a:endParaRPr lang="en-US" sz="1650" dirty="0"/>
           </a:p>
@@ -12564,7 +12498,7 @@
               <a:buNone/>
             </a:pPr>
             <a:r>
-              <a:rPr lang="en-US" sz="2400" dirty="0" spc="-11" kern="0">
+              <a:rPr lang="en-US" sz="2400" dirty="0" spc="4" kern="0">
                 <a:solidFill>
                   <a:srgbClr val="E4E1D8"/>
                 </a:solidFill>
@@ -12572,10 +12506,10 @@
                 <a:ea typeface="Be Vietnam Pro" pitchFamily="34" charset="-122"/>
                 <a:cs typeface="Be Vietnam Pro" pitchFamily="34" charset="-120"/>
               </a:rPr>
-              <a:t>Ngôn</a:t>
-            </a:r>
-            <a:r>
-              <a:rPr lang="en-US" sz="2400" dirty="0" spc="3" kern="0">
+              <a:t>Bộ</a:t>
+            </a:r>
+            <a:r>
+              <a:rPr lang="en-US" sz="2400" dirty="0" spc="22" kern="0">
                 <a:solidFill>
                   <a:srgbClr val="E4E1D8"/>
                 </a:solidFill>
@@ -12583,10 +12517,10 @@
                 <a:ea typeface="Be Vietnam Pro" pitchFamily="34" charset="-122"/>
                 <a:cs typeface="Be Vietnam Pro" pitchFamily="34" charset="-120"/>
               </a:rPr>
-              <a:t> ngữ</a:t>
-            </a:r>
-            <a:r>
-              <a:rPr lang="en-US" sz="2400" dirty="0" spc="11" kern="0">
+              <a:t> dựng</a:t>
+            </a:r>
+            <a:r>
+              <a:rPr lang="en-US" sz="2400" dirty="0" spc="-8" kern="0">
                 <a:solidFill>
                   <a:srgbClr val="E4E1D8"/>
                 </a:solidFill>
@@ -12594,7 +12528,7 @@
                 <a:ea typeface="Be Vietnam Pro" pitchFamily="34" charset="-122"/>
                 <a:cs typeface="Be Vietnam Pro" pitchFamily="34" charset="-120"/>
               </a:rPr>
-              <a:t> đánh</a:t>
+              <a:t> cây</a:t>
             </a:r>
             <a:r>
               <a:rPr lang="en-US" sz="2400" dirty="0" spc="1" kern="0">
@@ -12605,10 +12539,10 @@
                 <a:ea typeface="Be Vietnam Pro" pitchFamily="34" charset="-122"/>
                 <a:cs typeface="Be Vietnam Pro" pitchFamily="34" charset="-120"/>
               </a:rPr>
-              <a:t> dấu</a:t>
-            </a:r>
-            <a:r>
-              <a:rPr lang="en-US" sz="2400" dirty="0" spc="4" kern="0">
+              <a:t> thẻ</a:t>
+            </a:r>
+            <a:r>
+              <a:rPr lang="en-US" sz="2400" dirty="0" spc="2" kern="0">
                 <a:solidFill>
                   <a:srgbClr val="E4E1D8"/>
                 </a:solidFill>
@@ -12616,10 +12550,10 @@
                 <a:ea typeface="Be Vietnam Pro" pitchFamily="34" charset="-122"/>
                 <a:cs typeface="Be Vietnam Pro" pitchFamily="34" charset="-120"/>
               </a:rPr>
-              <a:t> mở</a:t>
-            </a:r>
-            <a:r>
-              <a:rPr lang="en-US" sz="2400" dirty="0" spc="-17" kern="0">
+              <a:t> lồng</a:t>
+            </a:r>
+            <a:r>
+              <a:rPr lang="en-US" sz="2400" dirty="0" spc="0" kern="0">
                 <a:solidFill>
                   <a:srgbClr val="E4E1D8"/>
                 </a:solidFill>
@@ -12627,7 +12561,18 @@
                 <a:ea typeface="Be Vietnam Pro" pitchFamily="34" charset="-122"/>
                 <a:cs typeface="Be Vietnam Pro" pitchFamily="34" charset="-120"/>
               </a:rPr>
-              <a:t> rộng</a:t>
+              <a:t> nhau:</a:t>
+            </a:r>
+            <a:r>
+              <a:rPr lang="en-US" sz="2400" dirty="0" spc="1" kern="0">
+                <a:solidFill>
+                  <a:srgbClr val="E4E1D8"/>
+                </a:solidFill>
+                <a:latin typeface="Be Vietnam Pro" pitchFamily="34" charset="0"/>
+                <a:ea typeface="Be Vietnam Pro" pitchFamily="34" charset="-122"/>
+                <a:cs typeface="Be Vietnam Pro" pitchFamily="34" charset="-120"/>
+              </a:rPr>
+              <a:t> mẫu Builder</a:t>
             </a:r>
             <a:endParaRPr lang="en-US" sz="2400" dirty="0"/>
           </a:p>

</xml_diff>